<commit_message>
Update the deck to the e5-base-v2 submission
Slides 2, 4, 6, 8, 9, 10 and 11 and the speaker notes now show the
submitted e5-base-v2 result (NDCG@10 0.1151, MRR@10 0.0986), the 10-config
ablation chart, the query:/passage: prefixes in the architecture diagram,
and a roadmap that follows from the new result.
</commit_message>
<xml_diff>
--- a/submission/Thapar_Trace_Submission_ppt.pptx
+++ b/submission/Thapar_Trace_Submission_ppt.pptx
@@ -608,7 +608,7 @@
           <a:lstStyle/>
           <a:p>
             <a:r>
-              <a:t>The lesson from nine real ablations: the only wins came from keeping the general-purpose recipe and giving it more capacity and more context; every specialized swap lost. Next steps follow that: re-test HyDE, multi-view and front-loading on top of mpnet (they may behave differently on a larger encoder); run mpnet at 256 tokens to isolate the gain from model size (384→512 alone was +2.9%); then validate cross-version retrieval on real multi-version repositories — every step still measured against the current best.</a:t>
+              <a:t>The lesson from ten real ablations: the gains came from picking a stronger general retrieval model — e5-base-v2, trained for query→passage retrieval, beat a same-size sentence-similarity model by a third — while every code-specialized swap lost. Next steps: re-test HyDE, multi-view and front-loading on top of e5; try e5-large-v2 within the CPU budget; then validate cross-version retrieval on real multi-version repositories — every step still measured against the current best.</a:t>
             </a:r>
           </a:p>
         </p:txBody>
@@ -975,7 +975,7 @@
           <a:lstStyle/>
           <a:p>
             <a:r>
-              <a:t>One CPU-friendly embedding model at the center, picked by measurement (submitted: all-mpnet-base-v2, 512-token window). Query path: preprocess + code-flavored HyDE. Snippet path: preprocess + optional multi-view (raw + AST-normalized + identifier bag) fused into one vector so the system stays a pure MTEB encoder. Score merges the two, with optional cross-version disambiguation for near-duplicate versions of the same snippet.</a:t>
+              <a:t>One CPU-friendly embedding model at the center, picked by measurement (submitted: e5-base-v2 with its query:/passage: prefixes, 512-token window). Query path: preprocess + code-flavored HyDE. Snippet path: preprocess + optional multi-view (raw + AST-normalized + identifier bag) fused into one vector so the system stays a pure MTEB encoder. Score merges the two, with optional cross-version disambiguation for near-duplicate versions of the same snippet.</a:t>
             </a:r>
           </a:p>
         </p:txBody>
@@ -1115,7 +1115,7 @@
           <a:lstStyle/>
           <a:p>
             <a:r>
-              <a:t>Kept deliberately boring. Core ML: PyTorch CPU, sentence-transformers, MTEB as the official scorer — the same one the leaderboard uses. Retrieval signals: NumPy for dense scoring, rank-bm25 for sparse, Python's own ast module for structural normalization (no third-party parser). Reproducibility: Docker for one-command runs, 77 offline tests, and a GitHub-Actions-ready CLI. Nothing exotic; everything runs where the judges will run it.</a:t>
+              <a:t>Kept deliberately boring. Core ML: PyTorch CPU, sentence-transformers, MTEB as the official scorer — the same one the leaderboard uses. Retrieval signals: NumPy for dense scoring, rank-bm25 for sparse, Python's own ast module for structural normalization (no third-party parser). Reproducibility: Docker for one-command runs, 78 offline tests, and a GitHub-Actions-ready CLI. Nothing exotic; everything runs where the judges will run it.</a:t>
             </a:r>
           </a:p>
         </p:txBody>
@@ -1255,7 +1255,7 @@
           <a:lstStyle/>
           <a:p>
             <a:r>
-              <a:t>Submitted: all-mpnet-base-v2 with a 512-token window, NDCG@10 = 0.0861, MRR@10 = 0.0733 on the real CoIR AppsRetrieval test split via MTEB — +30.1% over the MiniLM baseline (0.0662). Nine configs measured, one kept. The pipeline differentiators on the left all lost to baseline on MiniLM — multi-view (−22%), HyDE (−6%), front-load keywords (−2.4%) — and so did every specialized model swap: retrieval-tuned (−27%), UniXcoder (−34.5%), CodeSearchNet (−50%). What won was baseline's recipe with more capacity (mpnet at 384 tokens, +26.5%), then a longer window (512 tokens, +2.9% more). Limitations up front: the MiniLM→mpnet jump mixes size and window, and the dropped features haven't been re-measured on mpnet yet.</a:t>
+              <a:t>Submitted: e5-base-v2 with its query:/passage: prefixes and a 512-token window, NDCG@10 = 0.1151, MRR@10 = 0.0986 on the real CoIR AppsRetrieval test split via MTEB — +73.9% over the MiniLM baseline (0.0662). Ten configs measured, one kept. The pipeline differentiators on the left all lost to baseline on MiniLM — multi-view (−22%), HyDE (−6%), front-load keywords (−2.4%) — and so did every code-specialized model: UniXcoder (−34.5%), CodeSearchNet (−50%). What won was a stronger general model: mpnet (+30.1% at 512 tokens), then e5-base-v2, the same size but trained for query→passage retrieval (+33.7% over mpnet). Limitations up front: larger models are untested within the CPU budget, and the dropped features haven't been re-measured on e5.</a:t>
             </a:r>
           </a:p>
         </p:txBody>
@@ -5711,7 +5711,7 @@
                 </a:solidFill>
                 <a:latin typeface="Calibri"/>
               </a:rPr>
-              <a:t>docs/ablation_log.md — 9 real experiments, 7 dropped, 1 kept (+30.1%); every row reproducible from a config file.</a:t>
+              <a:t>docs/ablation_log.md — 10 real experiments, 8 dropped, 1 kept (+73.9%); every row reproducible from a config file.</a:t>
             </a:r>
           </a:p>
         </p:txBody>
@@ -6489,7 +6489,7 @@
                 </a:solidFill>
                 <a:latin typeface="Calibri"/>
               </a:rPr>
-              <a:t>9</a:t>
+              <a:t>10</a:t>
             </a:r>
           </a:p>
           <a:p>
@@ -6550,7 +6550,7 @@
                 </a:solidFill>
                 <a:latin typeface="Calibri"/>
               </a:rPr>
-              <a:t>7</a:t>
+              <a:t>8</a:t>
             </a:r>
           </a:p>
           <a:p>
@@ -6611,7 +6611,7 @@
                 </a:solidFill>
                 <a:latin typeface="Calibri"/>
               </a:rPr>
-              <a:t>77</a:t>
+              <a:t>78</a:t>
             </a:r>
           </a:p>
           <a:p>
@@ -8011,7 +8011,7 @@
                 </a:solidFill>
                 <a:latin typeface="Calibri"/>
               </a:rPr>
-              <a:t>9 configs measured, 7 dropped, mpnet-512 kept (+30.1%)</a:t>
+              <a:t>10 configs measured, 8 dropped, e5-base kept (+73.9%)</a:t>
             </a:r>
           </a:p>
           <a:p>
@@ -8166,7 +8166,7 @@
                 </a:solidFill>
                 <a:latin typeface="Calibri"/>
               </a:rPr>
-              <a:t>0.0861</a:t>
+              <a:t>0.1151</a:t>
             </a:r>
           </a:p>
           <a:p>
@@ -8321,7 +8321,7 @@
                 </a:solidFill>
                 <a:latin typeface="Calibri"/>
               </a:rPr>
-              <a:t>9</a:t>
+              <a:t>10</a:t>
             </a:r>
           </a:p>
         </p:txBody>
@@ -8457,7 +8457,7 @@
                 </a:solidFill>
                 <a:latin typeface="Calibri"/>
               </a:rPr>
-              <a:t>+30.1%</a:t>
+              <a:t>+73.9%</a:t>
             </a:r>
           </a:p>
         </p:txBody>
@@ -8593,7 +8593,7 @@
                 </a:solidFill>
                 <a:latin typeface="Calibri"/>
               </a:rPr>
-              <a:t>77</a:t>
+              <a:t>78</a:t>
             </a:r>
           </a:p>
         </p:txBody>
@@ -9307,7 +9307,7 @@
                 </a:solidFill>
                 <a:latin typeface="Calibri"/>
               </a:rPr>
-              <a:t>THE SCOREBOARD  ·  SUBMITTED: mpnet-512</a:t>
+              <a:t>THE SCOREBOARD  ·  SUBMITTED: e5-base-v2</a:t>
             </a:r>
           </a:p>
         </p:txBody>
@@ -9352,7 +9352,7 @@
                 </a:solidFill>
                 <a:latin typeface="Calibri"/>
               </a:rPr>
-              <a:t>NDCG@10 = 0.0861</a:t>
+              <a:t>NDCG@10 = 0.1151</a:t>
             </a:r>
           </a:p>
         </p:txBody>
@@ -9394,7 +9394,7 @@
                 </a:solidFill>
                 <a:latin typeface="Calibri"/>
               </a:rPr>
-              <a:t>MRR@10 = 0.0733   ·   +30.1% over baseline</a:t>
+              <a:t>MRR@10 = 0.0986   ·   +73.9% over baseline</a:t>
             </a:r>
           </a:p>
         </p:txBody>
@@ -9529,7 +9529,7 @@
                 </a:solidFill>
                 <a:latin typeface="Calibri"/>
               </a:rPr>
-              <a:t>9</a:t>
+              <a:t>10</a:t>
             </a:r>
           </a:p>
           <a:p>
@@ -9596,7 +9596,7 @@
                 </a:solidFill>
                 <a:latin typeface="Calibri"/>
               </a:rPr>
-              <a:t>7</a:t>
+              <a:t>8</a:t>
             </a:r>
           </a:p>
           <a:p>
@@ -9685,7 +9685,7 @@
                 </a:solidFill>
                 <a:latin typeface="Calibri"/>
               </a:rPr>
-              <a:t>kept: mpnet-512</a:t>
+              <a:t>kept: e5-base</a:t>
             </a:r>
           </a:p>
         </p:txBody>
@@ -9730,7 +9730,7 @@
                 </a:solidFill>
                 <a:latin typeface="Calibri"/>
               </a:rPr>
-              <a:t>77</a:t>
+              <a:t>78</a:t>
             </a:r>
           </a:p>
           <a:p>
@@ -12531,6 +12531,22 @@
               </a:lnSpc>
             </a:pPr>
             <a:r>
+              <a:rPr sz="1150" b="0" i="0">
+                <a:solidFill>
+                  <a:srgbClr val="14142B"/>
+                </a:solidFill>
+                <a:latin typeface="Calibri"/>
+              </a:rPr>
+              <a:t>+ “query: ” prefix</a:t>
+            </a:r>
+          </a:p>
+          <a:p>
+            <a:pPr algn="ctr">
+              <a:lnSpc>
+                <a:spcPct val="105000"/>
+              </a:lnSpc>
+            </a:pPr>
+            <a:r>
               <a:rPr sz="1000" b="0" i="1">
                 <a:solidFill>
                   <a:srgbClr val="6B6B76"/>
@@ -12614,7 +12630,7 @@
                 </a:solidFill>
                 <a:latin typeface="Calibri"/>
               </a:rPr>
-              <a:t>mpnet, 512 tokens</a:t>
+              <a:t>e5-base-v2</a:t>
             </a:r>
           </a:p>
         </p:txBody>
@@ -12752,7 +12768,7 @@
                 </a:solidFill>
                 <a:latin typeface="Calibri"/>
               </a:rPr>
-              <a:t>+ long-snippet chunking</a:t>
+              <a:t>+ chunking + “passage: ”</a:t>
             </a:r>
           </a:p>
           <a:p>
@@ -12845,7 +12861,7 @@
                 </a:solidFill>
                 <a:latin typeface="Calibri"/>
               </a:rPr>
-              <a:t>mpnet, 512 tokens</a:t>
+              <a:t>e5-base-v2</a:t>
             </a:r>
           </a:p>
           <a:p>
@@ -13309,7 +13325,7 @@
                 </a:solidFill>
                 <a:latin typeface="Calibri"/>
               </a:rPr>
-              <a:t>Submitted: all-mpnet-base-v2, 512-token window, CPU-only. Grey items are built and switchable by config, but lost on the real split and are off.</a:t>
+              <a:t>Submitted: e5-base-v2, 512-token window, CPU-only. Grey items are built and switchable by config, but lost on the real split and are off.</a:t>
             </a:r>
           </a:p>
         </p:txBody>
@@ -13657,7 +13673,7 @@
                 </a:solidFill>
                 <a:latin typeface="Calibri"/>
               </a:rPr>
-              <a:t>whitespace-normalized</a:t>
+              <a:t>“query: ” + normalized text</a:t>
             </a:r>
           </a:p>
         </p:txBody>
@@ -13808,7 +13824,7 @@
                 </a:solidFill>
                 <a:latin typeface="Calibri"/>
               </a:rPr>
-              <a:t>768-d vector (mpnet)</a:t>
+              <a:t>768-d vector (e5)</a:t>
             </a:r>
           </a:p>
         </p:txBody>
@@ -15986,7 +16002,7 @@
                 </a:solidFill>
                 <a:latin typeface="Calibri"/>
               </a:rPr>
-              <a:t>Docker   ·   pytest — 77 offline tests   ·   GitHub Actions-ready CLI</a:t>
+              <a:t>Docker   ·   pytest — 78 offline tests   ·   GitHub Actions-ready CLI</a:t>
             </a:r>
           </a:p>
         </p:txBody>
@@ -16116,7 +16132,7 @@
                 </a:solidFill>
                 <a:latin typeface="Calibri"/>
               </a:rPr>
-              <a:t>77</a:t>
+              <a:t>78</a:t>
             </a:r>
           </a:p>
           <a:p>
@@ -16177,7 +16193,7 @@
                 </a:solidFill>
                 <a:latin typeface="Calibri"/>
               </a:rPr>
-              <a:t>9</a:t>
+              <a:t>10</a:t>
             </a:r>
           </a:p>
           <a:p>
@@ -19333,7 +19349,7 @@
                 </a:solidFill>
                 <a:latin typeface="Calibri"/>
               </a:rPr>
-              <a:t>NDCG@10, real CoIR AppsRetrieval split  ·  9 configs, 1 kept</a:t>
+              <a:t>NDCG@10, real CoIR AppsRetrieval split  ·  10 configs, 1 kept</a:t>
             </a:r>
           </a:p>
         </p:txBody>
@@ -19375,7 +19391,7 @@
                 </a:solidFill>
                 <a:latin typeface="Calibri"/>
               </a:rPr>
-              <a:t>Submitted: mpnet-512 — MRR@10 0.0733 (baseline 0.0561).</a:t>
+              <a:t>Submitted: e5-base-v2 — MRR@10 0.0986 (baseline 0.0561).</a:t>
             </a:r>
           </a:p>
         </p:txBody>
@@ -19396,8 +19412,8 @@
         </p:blipFill>
         <p:spPr>
           <a:xfrm>
-            <a:off x="5990932" y="2478024"/>
-            <a:ext cx="5199710" cy="2642615"/>
+            <a:off x="6130515" y="2478024"/>
+            <a:ext cx="4920545" cy="2642615"/>
           </a:xfrm>
           <a:prstGeom prst="rect">
             <a:avLst/>
@@ -19554,7 +19570,7 @@
                 </a:solidFill>
                 <a:latin typeface="Calibri"/>
               </a:rPr>
-              <a:t>—  MiniLM→mpnet mixes size and window; 384→512 alone added +2.9%</a:t>
+              <a:t>—  Larger retrieval models (e.g. e5-large) untested — ~3× the CPU time</a:t>
             </a:r>
           </a:p>
           <a:p>
@@ -19576,7 +19592,7 @@
                 </a:solidFill>
                 <a:latin typeface="Calibri"/>
               </a:rPr>
-              <a:t>—  HyDE, multi-view, front-load not yet re-measured on top of mpnet</a:t>
+              <a:t>—  HyDE, multi-view, front-load not yet re-measured on top of e5</a:t>
             </a:r>
           </a:p>
         </p:txBody>
@@ -19785,7 +19801,7 @@
                 </a:solidFill>
                 <a:latin typeface="Calibri"/>
               </a:rPr>
-              <a:t>Nine configs on the real split. Only the general-purpose recipe at 5× the size beat baseline (mpnet, +26.5%), and a 512-token window added +2.9% more. Every specialized swap (retrieval-tuned, CodeSearchNet, UniXcoder) lost — the roadmap follows that evidence.</a:t>
+              <a:t>Ten configs on the real split. The winner, e5-base-v2, is the same size as mpnet but trained for query→passage retrieval: +73.9% over baseline, +33.7% over mpnet. Every code-specialized swap (CodeSearchNet, UniXcoder) lost — the roadmap follows that evidence.</a:t>
             </a:r>
           </a:p>
         </p:txBody>
@@ -19918,7 +19934,7 @@
                 </a:solidFill>
                 <a:latin typeface="Calibri"/>
               </a:rPr>
-              <a:t>Re-test on mpnet</a:t>
+              <a:t>Re-test on e5</a:t>
             </a:r>
           </a:p>
         </p:txBody>
@@ -20051,7 +20067,7 @@
                 </a:solidFill>
                 <a:latin typeface="Calibri"/>
               </a:rPr>
-              <a:t>HyDE, multi-view and front-loading lost on MiniLM; a 5× larger encoder may use them differently.</a:t>
+              <a:t>HyDE, multi-view and front-loading lost on MiniLM; the stronger e5 encoder may use them differently.</a:t>
             </a:r>
           </a:p>
         </p:txBody>
@@ -20149,7 +20165,7 @@
                 </a:solidFill>
                 <a:latin typeface="Calibri"/>
               </a:rPr>
-              <a:t>Split size vs window</a:t>
+              <a:t>Scale the winner</a:t>
             </a:r>
           </a:p>
         </p:txBody>
@@ -20282,7 +20298,7 @@
                 </a:solidFill>
                 <a:latin typeface="Calibri"/>
               </a:rPr>
-              <a:t>384→512 alone added +2.9%; run mpnet at 256 tokens to isolate the gain from model size.</a:t>
+              <a:t>e5-large-v2 is the natural next test, at roughly 3× the CPU time.</a:t>
             </a:r>
           </a:p>
         </p:txBody>

</xml_diff>

<commit_message>
Tighten the deck's claims to match the evidence
- Slide 2: screening ranks on the score, then the top teams get a hands-on
  review; the deck no longer says there is no demo or jury.
- Slide 3: the right column is what was built and measured, with a caption
  saying HyDE and multi-view lost and are off in the submission.
- Slide 5: real-run demo output, a latency figure that holds across runs
  (< 0.1 ms), and the real-model cost: the full 12,530-text eval in 84 min
  on a free Kaggle CPU.
- Slide 6: replace the "GitHub Actions-ready" claim (there is no workflow)
  with the Makefile; match slide 5's latency.
- Slide 9: drop an unverifiable publication claim.
- Slide 10: note that the e5-base-v2 score matches the published CoIR result.
- Speaker notes: fix the architecture path, and replace template notes on the
  title and closing slides; add notes to the checklist slide.
</commit_message>
<xml_diff>
--- a/submission/Thapar_Trace_Submission_ppt.pptx
+++ b/submission/Thapar_Trace_Submission_ppt.pptx
@@ -521,8 +521,7 @@
           <a:lstStyle/>
           <a:p>
             <a:r>
-              <a:rPr lang="en-US" dirty="0"/>
-              <a:t>Opening slide for the 3rd edition of the PRISM Generative AI Hackathon. Replace the SAMSUNG PRISM pill with the official PRISM logo image if you have the asset. Confirm the academic year label (2026-27) before circulating.</a:t>
+              <a:t>Team Trace (solo), Thapar Institute of Engineering and Technology, Patiala. Theme 1, Agentic Code Intelligence: rank code snippets for a natural-language query. Submitted result: NDCG@10 = 0.1151 and MRR@10 = 0.0986 on the CoIR AppsRetrieval test split, using e5-base-v2 on CPU.</a:t>
             </a:r>
           </a:p>
         </p:txBody>
@@ -678,7 +677,77 @@
           <a:lstStyle/>
           <a:p>
             <a:r>
-              <a:t>What separates this submission: we verified the full MTEB scoring path end-to-end on our own local synthetic task before trusting a number on the real split (our metrics match MTEB's trec_eval to 1e-4). Every feature is logged config → NDCG@10 → MRR → kept/dropped, so nothing ships on a hunch. The index is versioned from day one, not bolted on. Limitations are reported next to results, on purpose.</a:t>
+              <a:t>What separates this submission: we verified the full MTEB scoring path end-to-end on our own local synthetic task before trusting a number on the real split (our metrics match MTEB's trec_eval to 1e-4), and our e5-base-v2 score (0.1151) matches the published CoIR result for that model (11.5). Every feature is logged config → NDCG@10 → MRR → kept/dropped, so nothing ships on a hunch. The index is versioned from day one, not bolted on. Limitations are reported next to results, on purpose.</a:t>
+            </a:r>
+          </a:p>
+        </p:txBody>
+      </p:sp>
+      <p:sp>
+        <p:nvSpPr>
+          <p:cNvPr id="4" name="Slide Number Placeholder 3"/>
+          <p:cNvSpPr>
+            <a:spLocks noGrp="1"/>
+          </p:cNvSpPr>
+          <p:nvPr>
+            <p:ph type="sldNum" idx="5" sz="quarter"/>
+          </p:nvPr>
+        </p:nvSpPr>
+        <p:spPr/>
+      </p:sp>
+    </p:spTree>
+  </p:cSld>
+  <p:clrMapOvr>
+    <a:masterClrMapping/>
+  </p:clrMapOvr>
+</p:notes>
+</file>
+
+<file path=ppt/notesSlides/notesSlide12.xml><?xml version="1.0" encoding="utf-8"?>
+<p:notes xmlns:a="http://schemas.openxmlformats.org/drawingml/2006/main" xmlns:p="http://schemas.openxmlformats.org/presentationml/2006/main" xmlns:r="http://schemas.openxmlformats.org/officeDocument/2006/relationships">
+  <p:cSld>
+    <p:spTree>
+      <p:nvGrpSpPr>
+        <p:cNvPr id="1" name=""/>
+        <p:cNvGrpSpPr/>
+        <p:nvPr/>
+      </p:nvGrpSpPr>
+      <p:grpSpPr>
+        <a:xfrm>
+          <a:off x="0" y="0"/>
+          <a:ext cx="0" cy="0"/>
+          <a:chOff x="0" y="0"/>
+          <a:chExt cx="0" cy="0"/>
+        </a:xfrm>
+      </p:grpSpPr>
+      <p:sp>
+        <p:nvSpPr>
+          <p:cNvPr id="2" name="Slide Image Placeholder 1"/>
+          <p:cNvSpPr>
+            <a:spLocks noGrp="1"/>
+          </p:cNvSpPr>
+          <p:nvPr>
+            <p:ph type="sldImg" idx="2"/>
+          </p:nvPr>
+        </p:nvSpPr>
+        <p:spPr/>
+      </p:sp>
+      <p:sp>
+        <p:nvSpPr>
+          <p:cNvPr id="3" name="Notes Placeholder 2"/>
+          <p:cNvSpPr>
+            <a:spLocks noGrp="1"/>
+          </p:cNvSpPr>
+          <p:nvPr>
+            <p:ph type="body" idx="3" sz="quarter"/>
+          </p:nvPr>
+        </p:nvSpPr>
+        <p:spPr/>
+        <p:txBody>
+          <a:bodyPr/>
+          <a:lstStyle/>
+          <a:p>
+            <a:r>
+              <a:t>Everything the guidelines ask for, and where it lives: the public repo with the release tag PRISM_GENAI_HACKATHON_Y2026, a README with a one-command Docker run, the demo video linked in the form, this deck as PPTX and PDF, the MTEB results JSON attached to the release, and the full ablation record in docs/ablation_log.md.</a:t>
             </a:r>
           </a:p>
         </p:txBody>
@@ -748,8 +817,7 @@
           <a:lstStyle/>
           <a:p>
             <a:r>
-              <a:rPr lang="en-US" dirty="0"/>
-              <a:t>Closing slide. Add the Google Form URL and a contact email before sharing. Edition 2 organising team for reference: Language AI - Sourabh Tiwari, Gaurav, Sanjeeth Pothireddy, Gorang Maniar; PRISM - Binny Lakra, Prakhar Chandrakar, Vishu Kumar; Kick-off and mentors - Giridhar Jakki, Deepraj Prabhakar Patkar (Language AI), Srimanu Prasad Nagaraju, Ashish Kumar (Tech Strategy).</a:t>
+              <a:t>Thank you. The code, the release with the results JSON, and the ablation log are public at github.com/Ajha2005/samsung-prism. Contact: Abhavya Jha, ajha2_be24@thapar.edu.</a:t>
             </a:r>
           </a:p>
         </p:txBody>
@@ -835,7 +903,7 @@
           <a:lstStyle/>
           <a:p>
             <a:r>
-              <a:t>One-sentence framing: given a natural-language query and a library of code snippets, return them ranked by relevance. Pure retrieval, no generation. Screening is a leaderboard on the CoIR AppsRetrieval test split, scored by MTEB with NDCG@10 and MRR — the outcome is a number, not a vote. The three constraints below aren't limitations we work around; they define the shape of the problem we're solving.</a:t>
+              <a:t>One-sentence framing: given a natural-language query and a library of code snippets, return them ranked by relevance. Pure retrieval, no generation. Screening ranks teams on the CoIR AppsRetrieval test split, scored by MTEB with NDCG@10 and MRR; the top teams then go to a hands-on review. The three constraints below aren't limitations we work around; they define the shape of the problem we're solving.</a:t>
             </a:r>
           </a:p>
         </p:txBody>
@@ -905,7 +973,7 @@
           <a:lstStyle/>
           <a:p>
             <a:r>
-              <a:t>Two-column contrast: what most teams reach for on the left, and where each of those choices actually falls apart on AppsRetrieval on the right. Note the cross-version gap — the P1 requirement isn't optional and it's usually bolted on at the end; we designed the index versioned from day one.</a:t>
+              <a:t>Three columns: what most teams reach for, where it breaks down on AppsRetrieval, and what we built for each gap. Everything on the right was built and measured on the real split: HyDE and multi-view lost to baseline and are off in the submission; what moved the score instead was a retrieval-trained encoder, e5-base-v2. Note the cross-version gap: P1 is usually bolted on at the end; we designed the index versioned from day one.</a:t>
             </a:r>
           </a:p>
         </p:txBody>
@@ -975,7 +1043,7 @@
           <a:lstStyle/>
           <a:p>
             <a:r>
-              <a:t>One CPU-friendly embedding model at the center, picked by measurement (submitted: e5-base-v2 with its query:/passage: prefixes, 512-token window). Query path: preprocess + code-flavored HyDE. Snippet path: preprocess + optional multi-view (raw + AST-normalized + identifier bag) fused into one vector so the system stays a pure MTEB encoder. Score merges the two, with optional cross-version disambiguation for near-duplicate versions of the same snippet.</a:t>
+              <a:t>One CPU-friendly embedding model at the center, picked by measurement (submitted: e5-base-v2, 512-token window, CPU only). Query path: whitespace normalization plus the 'query: ' prefix. Snippet path: cleanup, splitting of very long snippets into windows that are max-pooled back into one vector, plus the 'passage: ' prefix. Scoring is cosine similarity, with optional cross-version disambiguation for near-duplicate versions of the same snippet. Code-flavored HyDE and multi-view embedding are built and switchable by config, but lost on the real split, so they are off.</a:t>
             </a:r>
           </a:p>
         </p:txBody>
@@ -1045,7 +1113,7 @@
           <a:lstStyle/>
           <a:p>
             <a:r>
-              <a:t>The demo shows retrieval working on real behavioral queries — 'find two numbers that sum to a target', 'detect if a string is a palindrome' — with the right snippet ranked first in every case. This is the offline demo (hashing backend, no downloads), so the latency shown is that backend's: sub-millisecond per query. The pipeline and ranking code are the same ones the leaderboard run uses; the submitted model swaps in by config. No LLM in the ranking loop.</a:t>
+              <a:t>The demo shows retrieval working on real behavioral queries — 'find two numbers that sum to a target', 'detect if a string is a palindrome' — with the right snippet ranked first in every case. This is the offline demo (hashing backend, no downloads), so the latency shown is that backend's: under 0.1 ms per query. With the submitted model, the full real eval (3,765 long problem statements against 8,765 solutions) ran in 84 minutes on a free Kaggle CPU, no GPU. The pipeline and ranking code are the same ones the leaderboard run uses; the submitted model swaps in by config. No LLM in the ranking loop.</a:t>
             </a:r>
           </a:p>
         </p:txBody>
@@ -1115,7 +1183,7 @@
           <a:lstStyle/>
           <a:p>
             <a:r>
-              <a:t>Kept deliberately boring. Core ML: PyTorch CPU, sentence-transformers, MTEB as the official scorer — the same one the leaderboard uses. Retrieval signals: NumPy for dense scoring, rank-bm25 for sparse, Python's own ast module for structural normalization (no third-party parser). Reproducibility: Docker for one-command runs, 78 offline tests, and a GitHub-Actions-ready CLI. Nothing exotic; everything runs where the judges will run it.</a:t>
+              <a:t>Kept deliberately boring. Core ML: PyTorch CPU, sentence-transformers, MTEB as the official scorer — the same one the leaderboard uses. Retrieval signals: NumPy for dense scoring, rank-bm25 for sparse, Python's own ast module for structural normalization (no third-party parser). Reproducibility: Docker for one-command runs, 78 offline tests, and Makefile targets for every step. Nothing exotic; everything runs where the judges will run it.</a:t>
             </a:r>
           </a:p>
         </p:txBody>
@@ -5254,7 +5322,7 @@
                 </a:solidFill>
                 <a:latin typeface="Calibri"/>
               </a:rPr>
-              <a:t>Proven end-to-end against a real mteb.evaluate() run.</a:t>
+              <a:t>Proven end-to-end, and checked against a published number.</a:t>
             </a:r>
           </a:p>
         </p:txBody>
@@ -5387,7 +5455,7 @@
                 </a:solidFill>
                 <a:latin typeface="Calibri"/>
               </a:rPr>
-              <a:t>tests/test_submission_format.py — 6 tests lock the leaderboard file shape byte-for-byte to the problem statement.</a:t>
+              <a:t>Our e5-base-v2 run (0.1151) matches the published CoIR score for that model (11.5); 6 tests lock the file shape.</a:t>
             </a:r>
           </a:p>
         </p:txBody>
@@ -5711,7 +5779,7 @@
                 </a:solidFill>
                 <a:latin typeface="Calibri"/>
               </a:rPr>
-              <a:t>docs/ablation_log.md — 10 real experiments, 8 dropped, 1 kept (+73.9%); every row reproducible from a config file.</a:t>
+              <a:t>docs/ablation_log.md — 10 real experiments, 8 dropped, 1 kept (+73.9%); every row reproducible from the repo.</a:t>
             </a:r>
           </a:p>
         </p:txBody>
@@ -9219,7 +9287,7 @@
                 </a:solidFill>
                 <a:latin typeface="Calibri"/>
               </a:rPr>
-              <a:t>Scored by MTEB’s NDCG@10 and MRR on the CoIR AppsRetrieval test split: a real, objective leaderboard number decides the outcome — not a live demo or a jury.</a:t>
+              <a:t>Screening ranks teams on MTEB’s NDCG@10 and MRR over the CoIR AppsRetrieval test split; the top teams then go to a hands-on review of the code, deck and demo.</a:t>
             </a:r>
           </a:p>
         </p:txBody>
@@ -10586,7 +10654,7 @@
                 </a:solidFill>
                 <a:latin typeface="Calibri"/>
               </a:rPr>
-              <a:t>HOW WE DESIGNED FOR THIS</a:t>
+              <a:t>WHAT WE BUILT &amp; MEASURED</a:t>
             </a:r>
           </a:p>
         </p:txBody>
@@ -10600,7 +10668,7 @@
         <p:spPr>
           <a:xfrm>
             <a:off x="841248" y="2386584"/>
-            <a:ext cx="3395472" cy="850392"/>
+            <a:ext cx="3395472" cy="777240"/>
           </a:xfrm>
           <a:prstGeom prst="roundRect">
             <a:avLst>
@@ -10648,7 +10716,7 @@
         <p:spPr>
           <a:xfrm>
             <a:off x="4401312" y="2386584"/>
-            <a:ext cx="3395472" cy="850392"/>
+            <a:ext cx="3395472" cy="777240"/>
           </a:xfrm>
           <a:prstGeom prst="roundRect">
             <a:avLst>
@@ -10694,7 +10762,7 @@
         <p:spPr>
           <a:xfrm>
             <a:off x="7961376" y="2386584"/>
-            <a:ext cx="3395472" cy="850392"/>
+            <a:ext cx="3395472" cy="777240"/>
           </a:xfrm>
           <a:prstGeom prst="roundRect">
             <a:avLst>
@@ -10741,7 +10809,7 @@
         </p:nvSpPr>
         <p:spPr>
           <a:xfrm>
-            <a:off x="941832" y="2619756"/>
+            <a:off x="941832" y="2583180"/>
             <a:ext cx="384048" cy="384048"/>
           </a:xfrm>
           <a:prstGeom prst="ellipse">
@@ -10795,7 +10863,7 @@
         <p:spPr>
           <a:xfrm>
             <a:off x="1435608" y="2496312"/>
-            <a:ext cx="2663952" cy="630936"/>
+            <a:ext cx="2663952" cy="557784"/>
           </a:xfrm>
           <a:prstGeom prst="rect">
             <a:avLst/>
@@ -10840,7 +10908,7 @@
         <p:spPr>
           <a:xfrm>
             <a:off x="4584192" y="2496312"/>
-            <a:ext cx="3029712" cy="630936"/>
+            <a:ext cx="3029712" cy="557784"/>
           </a:xfrm>
           <a:prstGeom prst="rect">
             <a:avLst/>
@@ -10885,7 +10953,7 @@
         <p:spPr>
           <a:xfrm>
             <a:off x="8144256" y="2496312"/>
-            <a:ext cx="3029712" cy="630936"/>
+            <a:ext cx="3029712" cy="557784"/>
           </a:xfrm>
           <a:prstGeom prst="rect">
             <a:avLst/>
@@ -10929,7 +10997,7 @@
         </p:nvSpPr>
         <p:spPr>
           <a:xfrm>
-            <a:off x="4209288" y="2674620"/>
+            <a:off x="4209288" y="2638044"/>
             <a:ext cx="219456" cy="274320"/>
           </a:xfrm>
           <a:prstGeom prst="rect">
@@ -10971,7 +11039,7 @@
         </p:nvSpPr>
         <p:spPr>
           <a:xfrm>
-            <a:off x="7769352" y="2674620"/>
+            <a:off x="7769352" y="2638044"/>
             <a:ext cx="219456" cy="274320"/>
           </a:xfrm>
           <a:prstGeom prst="rect">
@@ -11013,8 +11081,8 @@
         </p:nvSpPr>
         <p:spPr>
           <a:xfrm>
-            <a:off x="841248" y="3364992"/>
-            <a:ext cx="3395472" cy="850392"/>
+            <a:off x="841248" y="3291840"/>
+            <a:ext cx="3395472" cy="777240"/>
           </a:xfrm>
           <a:prstGeom prst="roundRect">
             <a:avLst>
@@ -11061,8 +11129,8 @@
         </p:nvSpPr>
         <p:spPr>
           <a:xfrm>
-            <a:off x="4401312" y="3364992"/>
-            <a:ext cx="3395472" cy="850392"/>
+            <a:off x="4401312" y="3291840"/>
+            <a:ext cx="3395472" cy="777240"/>
           </a:xfrm>
           <a:prstGeom prst="roundRect">
             <a:avLst>
@@ -11107,8 +11175,8 @@
         </p:nvSpPr>
         <p:spPr>
           <a:xfrm>
-            <a:off x="7961376" y="3364992"/>
-            <a:ext cx="3395472" cy="850392"/>
+            <a:off x="7961376" y="3291840"/>
+            <a:ext cx="3395472" cy="777240"/>
           </a:xfrm>
           <a:prstGeom prst="roundRect">
             <a:avLst>
@@ -11155,7 +11223,7 @@
         </p:nvSpPr>
         <p:spPr>
           <a:xfrm>
-            <a:off x="941832" y="3598164"/>
+            <a:off x="941832" y="3488436"/>
             <a:ext cx="384048" cy="384048"/>
           </a:xfrm>
           <a:prstGeom prst="ellipse">
@@ -11208,8 +11276,8 @@
         </p:nvSpPr>
         <p:spPr>
           <a:xfrm>
-            <a:off x="1435608" y="3474720"/>
-            <a:ext cx="2663952" cy="630936"/>
+            <a:off x="1435608" y="3401568"/>
+            <a:ext cx="2663952" cy="557784"/>
           </a:xfrm>
           <a:prstGeom prst="rect">
             <a:avLst/>
@@ -11253,8 +11321,8 @@
         </p:nvSpPr>
         <p:spPr>
           <a:xfrm>
-            <a:off x="4584192" y="3474720"/>
-            <a:ext cx="3029712" cy="630936"/>
+            <a:off x="4584192" y="3401568"/>
+            <a:ext cx="3029712" cy="557784"/>
           </a:xfrm>
           <a:prstGeom prst="rect">
             <a:avLst/>
@@ -11298,8 +11366,8 @@
         </p:nvSpPr>
         <p:spPr>
           <a:xfrm>
-            <a:off x="8144256" y="3474720"/>
-            <a:ext cx="3029712" cy="630936"/>
+            <a:off x="8144256" y="3401568"/>
+            <a:ext cx="3029712" cy="557784"/>
           </a:xfrm>
           <a:prstGeom prst="rect">
             <a:avLst/>
@@ -11343,7 +11411,7 @@
         </p:nvSpPr>
         <p:spPr>
           <a:xfrm>
-            <a:off x="4209288" y="3653028"/>
+            <a:off x="4209288" y="3543300"/>
             <a:ext cx="219456" cy="274320"/>
           </a:xfrm>
           <a:prstGeom prst="rect">
@@ -11385,7 +11453,7 @@
         </p:nvSpPr>
         <p:spPr>
           <a:xfrm>
-            <a:off x="7769352" y="3653028"/>
+            <a:off x="7769352" y="3543300"/>
             <a:ext cx="219456" cy="274320"/>
           </a:xfrm>
           <a:prstGeom prst="rect">
@@ -11427,8 +11495,8 @@
         </p:nvSpPr>
         <p:spPr>
           <a:xfrm>
-            <a:off x="841248" y="4343400"/>
-            <a:ext cx="3395472" cy="850392"/>
+            <a:off x="841248" y="4197096"/>
+            <a:ext cx="3395472" cy="777240"/>
           </a:xfrm>
           <a:prstGeom prst="roundRect">
             <a:avLst>
@@ -11475,8 +11543,8 @@
         </p:nvSpPr>
         <p:spPr>
           <a:xfrm>
-            <a:off x="4401312" y="4343400"/>
-            <a:ext cx="3395472" cy="850392"/>
+            <a:off x="4401312" y="4197096"/>
+            <a:ext cx="3395472" cy="777240"/>
           </a:xfrm>
           <a:prstGeom prst="roundRect">
             <a:avLst>
@@ -11521,8 +11589,8 @@
         </p:nvSpPr>
         <p:spPr>
           <a:xfrm>
-            <a:off x="7961376" y="4343400"/>
-            <a:ext cx="3395472" cy="850392"/>
+            <a:off x="7961376" y="4197096"/>
+            <a:ext cx="3395472" cy="777240"/>
           </a:xfrm>
           <a:prstGeom prst="roundRect">
             <a:avLst>
@@ -11569,7 +11637,7 @@
         </p:nvSpPr>
         <p:spPr>
           <a:xfrm>
-            <a:off x="941832" y="4576572"/>
+            <a:off x="941832" y="4393692"/>
             <a:ext cx="384048" cy="384048"/>
           </a:xfrm>
           <a:prstGeom prst="ellipse">
@@ -11622,8 +11690,8 @@
         </p:nvSpPr>
         <p:spPr>
           <a:xfrm>
-            <a:off x="1435608" y="4453128"/>
-            <a:ext cx="2663952" cy="630936"/>
+            <a:off x="1435608" y="4306824"/>
+            <a:ext cx="2663952" cy="557784"/>
           </a:xfrm>
           <a:prstGeom prst="rect">
             <a:avLst/>
@@ -11667,8 +11735,8 @@
         </p:nvSpPr>
         <p:spPr>
           <a:xfrm>
-            <a:off x="4584192" y="4453128"/>
-            <a:ext cx="3029712" cy="630936"/>
+            <a:off x="4584192" y="4306824"/>
+            <a:ext cx="3029712" cy="557784"/>
           </a:xfrm>
           <a:prstGeom prst="rect">
             <a:avLst/>
@@ -11712,8 +11780,8 @@
         </p:nvSpPr>
         <p:spPr>
           <a:xfrm>
-            <a:off x="8144256" y="4453128"/>
-            <a:ext cx="3029712" cy="630936"/>
+            <a:off x="8144256" y="4306824"/>
+            <a:ext cx="3029712" cy="557784"/>
           </a:xfrm>
           <a:prstGeom prst="rect">
             <a:avLst/>
@@ -11757,7 +11825,7 @@
         </p:nvSpPr>
         <p:spPr>
           <a:xfrm>
-            <a:off x="4209288" y="4631436"/>
+            <a:off x="4209288" y="4448555"/>
             <a:ext cx="219456" cy="274320"/>
           </a:xfrm>
           <a:prstGeom prst="rect">
@@ -11799,7 +11867,7 @@
         </p:nvSpPr>
         <p:spPr>
           <a:xfrm>
-            <a:off x="7769352" y="4631436"/>
+            <a:off x="7769352" y="4448555"/>
             <a:ext cx="219456" cy="274320"/>
           </a:xfrm>
           <a:prstGeom prst="rect">
@@ -11841,8 +11909,8 @@
         </p:nvSpPr>
         <p:spPr>
           <a:xfrm>
-            <a:off x="841248" y="5321808"/>
-            <a:ext cx="3395472" cy="850392"/>
+            <a:off x="841248" y="5102352"/>
+            <a:ext cx="3395472" cy="777240"/>
           </a:xfrm>
           <a:prstGeom prst="roundRect">
             <a:avLst>
@@ -11889,8 +11957,8 @@
         </p:nvSpPr>
         <p:spPr>
           <a:xfrm>
-            <a:off x="4401312" y="5321808"/>
-            <a:ext cx="3395472" cy="850392"/>
+            <a:off x="4401312" y="5102352"/>
+            <a:ext cx="3395472" cy="777240"/>
           </a:xfrm>
           <a:prstGeom prst="roundRect">
             <a:avLst>
@@ -11935,8 +12003,8 @@
         </p:nvSpPr>
         <p:spPr>
           <a:xfrm>
-            <a:off x="7961376" y="5321808"/>
-            <a:ext cx="3395472" cy="850392"/>
+            <a:off x="7961376" y="5102352"/>
+            <a:ext cx="3395472" cy="777240"/>
           </a:xfrm>
           <a:prstGeom prst="roundRect">
             <a:avLst>
@@ -11983,7 +12051,7 @@
         </p:nvSpPr>
         <p:spPr>
           <a:xfrm>
-            <a:off x="941832" y="5554980"/>
+            <a:off x="941832" y="5298948"/>
             <a:ext cx="384048" cy="384048"/>
           </a:xfrm>
           <a:prstGeom prst="ellipse">
@@ -12036,8 +12104,8 @@
         </p:nvSpPr>
         <p:spPr>
           <a:xfrm>
-            <a:off x="1435608" y="5431536"/>
-            <a:ext cx="2663952" cy="630936"/>
+            <a:off x="1435608" y="5212080"/>
+            <a:ext cx="2663952" cy="557784"/>
           </a:xfrm>
           <a:prstGeom prst="rect">
             <a:avLst/>
@@ -12081,8 +12149,8 @@
         </p:nvSpPr>
         <p:spPr>
           <a:xfrm>
-            <a:off x="4584192" y="5431536"/>
-            <a:ext cx="3029712" cy="630936"/>
+            <a:off x="4584192" y="5212080"/>
+            <a:ext cx="3029712" cy="557784"/>
           </a:xfrm>
           <a:prstGeom prst="rect">
             <a:avLst/>
@@ -12126,8 +12194,8 @@
         </p:nvSpPr>
         <p:spPr>
           <a:xfrm>
-            <a:off x="8144256" y="5431536"/>
-            <a:ext cx="3029712" cy="630936"/>
+            <a:off x="8144256" y="5212080"/>
+            <a:ext cx="3029712" cy="557784"/>
           </a:xfrm>
           <a:prstGeom prst="rect">
             <a:avLst/>
@@ -12171,7 +12239,7 @@
         </p:nvSpPr>
         <p:spPr>
           <a:xfrm>
-            <a:off x="4209288" y="5609844"/>
+            <a:off x="4209288" y="5353812"/>
             <a:ext cx="219456" cy="274320"/>
           </a:xfrm>
           <a:prstGeom prst="rect">
@@ -12213,7 +12281,7 @@
         </p:nvSpPr>
         <p:spPr>
           <a:xfrm>
-            <a:off x="7769352" y="5609844"/>
+            <a:off x="7769352" y="5353812"/>
             <a:ext cx="219456" cy="274320"/>
           </a:xfrm>
           <a:prstGeom prst="rect">
@@ -12243,6 +12311,48 @@
                 <a:latin typeface="Calibri"/>
               </a:rPr>
               <a:t>›</a:t>
+            </a:r>
+          </a:p>
+        </p:txBody>
+      </p:sp>
+      <p:sp>
+        <p:nvSpPr>
+          <p:cNvPr id="45" name="TextBox 44"/>
+          <p:cNvSpPr txBox="1"/>
+          <p:nvPr/>
+        </p:nvSpPr>
+        <p:spPr>
+          <a:xfrm>
+            <a:off x="841248" y="5952744"/>
+            <a:ext cx="10515600" cy="237744"/>
+          </a:xfrm>
+          <a:prstGeom prst="rect">
+            <a:avLst/>
+          </a:prstGeom>
+          <a:noFill/>
+        </p:spPr>
+        <p:txBody>
+          <a:bodyPr wrap="square" lIns="0" rIns="0" tIns="0" bIns="0" anchor="ctr">
+            <a:spAutoFit/>
+          </a:bodyPr>
+          <a:lstStyle/>
+          <a:p>
+            <a:pPr algn="l">
+              <a:spcBef>
+                <a:spcPts val="0"/>
+              </a:spcBef>
+              <a:spcAft>
+                <a:spcPts val="600"/>
+              </a:spcAft>
+            </a:pPr>
+            <a:r>
+              <a:rPr sz="1000" b="0" i="1">
+                <a:solidFill>
+                  <a:srgbClr val="6B6B76"/>
+                </a:solidFill>
+                <a:latin typeface="Calibri"/>
+              </a:rPr>
+              <a:t>Measured on the real split: rows 1 and 3 (HyDE, multi-view) lost and are off; what moved the score was a retrieval-trained encoder, e5-base-v2.</a:t>
             </a:r>
           </a:p>
         </p:txBody>
@@ -14203,7 +14313,7 @@
         <p:spPr>
           <a:xfrm>
             <a:off x="841248" y="1874519"/>
-            <a:ext cx="6720840" cy="2880360"/>
+            <a:ext cx="6720840" cy="2788920"/>
           </a:xfrm>
           <a:prstGeom prst="roundRect">
             <a:avLst>
@@ -14381,7 +14491,7 @@
         <p:spPr>
           <a:xfrm>
             <a:off x="1161288" y="2468879"/>
-            <a:ext cx="6080759" cy="2103120"/>
+            <a:ext cx="6080759" cy="2011679"/>
           </a:xfrm>
           <a:prstGeom prst="rect">
             <a:avLst/>
@@ -14542,7 +14652,7 @@
                 </a:solidFill>
                 <a:latin typeface="Courier New"/>
               </a:rPr>
-              <a:t>mean query latency: 0.03 ms  (36,000+ q/s)</a:t>
+              <a:t>mean query latency: 0.03 ms (31584 q/s)</a:t>
             </a:r>
           </a:p>
         </p:txBody>
@@ -14556,7 +14666,7 @@
         <p:spPr>
           <a:xfrm>
             <a:off x="7836408" y="1874519"/>
-            <a:ext cx="3520439" cy="1303020"/>
+            <a:ext cx="3520439" cy="1257300"/>
           </a:xfrm>
           <a:prstGeom prst="roundRect">
             <a:avLst>
@@ -14602,7 +14712,7 @@
         <p:spPr>
           <a:xfrm>
             <a:off x="7973568" y="2039112"/>
-            <a:ext cx="3246120" cy="973836"/>
+            <a:ext cx="3246120" cy="928116"/>
           </a:xfrm>
           <a:prstGeom prst="rect">
             <a:avLst/>
@@ -14630,7 +14740,7 @@
                 </a:solidFill>
                 <a:latin typeface="Calibri"/>
               </a:rPr>
-              <a:t>0.03 ms</a:t>
+              <a:t>&lt; 0.1 ms</a:t>
             </a:r>
           </a:p>
           <a:p>
@@ -14639,7 +14749,7 @@
                 <a:spcPts val="0"/>
               </a:spcBef>
               <a:spcAft>
-                <a:spcPts val="600"/>
+                <a:spcPts val="0"/>
               </a:spcAft>
             </a:pPr>
             <a:r>
@@ -14649,7 +14759,7 @@
                 </a:solidFill>
                 <a:latin typeface="Calibri"/>
               </a:rPr>
-              <a:t>mean query latency (offline demo)</a:t>
+              <a:t>per query, offline demo backend</a:t>
             </a:r>
           </a:p>
         </p:txBody>
@@ -14662,8 +14772,8 @@
         </p:nvSpPr>
         <p:spPr>
           <a:xfrm>
-            <a:off x="7836408" y="3451860"/>
-            <a:ext cx="3520439" cy="1303020"/>
+            <a:off x="7836408" y="3406139"/>
+            <a:ext cx="3520439" cy="1257300"/>
           </a:xfrm>
           <a:prstGeom prst="roundRect">
             <a:avLst>
@@ -14708,8 +14818,8 @@
         </p:nvSpPr>
         <p:spPr>
           <a:xfrm>
-            <a:off x="7973568" y="3616452"/>
-            <a:ext cx="3246120" cy="973836"/>
+            <a:off x="7973568" y="3570732"/>
+            <a:ext cx="3246120" cy="928116"/>
           </a:xfrm>
           <a:prstGeom prst="rect">
             <a:avLst/>
@@ -14737,7 +14847,7 @@
                 </a:solidFill>
                 <a:latin typeface="Calibri"/>
               </a:rPr>
-              <a:t>36,000+</a:t>
+              <a:t>84 min</a:t>
             </a:r>
           </a:p>
           <a:p>
@@ -14746,7 +14856,7 @@
                 <a:spcPts val="0"/>
               </a:spcBef>
               <a:spcAft>
-                <a:spcPts val="600"/>
+                <a:spcPts val="0"/>
               </a:spcAft>
             </a:pPr>
             <a:r>
@@ -14756,7 +14866,26 @@
                 </a:solidFill>
                 <a:latin typeface="Calibri"/>
               </a:rPr>
-              <a:t>queries / second (offline demo)</a:t>
+              <a:t>full real eval, e5-base-v2</a:t>
+            </a:r>
+          </a:p>
+          <a:p>
+            <a:pPr algn="ctr">
+              <a:spcBef>
+                <a:spcPts val="0"/>
+              </a:spcBef>
+              <a:spcAft>
+                <a:spcPts val="0"/>
+              </a:spcAft>
+            </a:pPr>
+            <a:r>
+              <a:rPr sz="1100" b="0" i="0">
+                <a:solidFill>
+                  <a:srgbClr val="6B6B76"/>
+                </a:solidFill>
+                <a:latin typeface="Calibri"/>
+              </a:rPr>
+              <a:t>12,530 texts on a free Kaggle CPU</a:t>
             </a:r>
           </a:p>
         </p:txBody>
@@ -14769,7 +14898,7 @@
         </p:nvSpPr>
         <p:spPr>
           <a:xfrm>
-            <a:off x="841248" y="4727447"/>
+            <a:off x="841248" y="4636007"/>
             <a:ext cx="10515600" cy="256032"/>
           </a:xfrm>
           <a:prstGeom prst="rect">
@@ -14811,7 +14940,7 @@
         </p:nvSpPr>
         <p:spPr>
           <a:xfrm>
-            <a:off x="841248" y="4983479"/>
+            <a:off x="841248" y="4892040"/>
             <a:ext cx="3352800" cy="1051560"/>
           </a:xfrm>
           <a:prstGeom prst="roundRect">
@@ -14859,7 +14988,7 @@
         </p:nvSpPr>
         <p:spPr>
           <a:xfrm>
-            <a:off x="987552" y="5074919"/>
+            <a:off x="987552" y="4983479"/>
             <a:ext cx="3060192" cy="365760"/>
           </a:xfrm>
           <a:prstGeom prst="rect">
@@ -14904,7 +15033,7 @@
         </p:nvSpPr>
         <p:spPr>
           <a:xfrm>
-            <a:off x="987552" y="5513831"/>
+            <a:off x="987552" y="5422392"/>
             <a:ext cx="3060192" cy="457200"/>
           </a:xfrm>
           <a:prstGeom prst="rect">
@@ -14965,7 +15094,7 @@
         </p:nvSpPr>
         <p:spPr>
           <a:xfrm>
-            <a:off x="4422648" y="4983479"/>
+            <a:off x="4422648" y="4892040"/>
             <a:ext cx="3352800" cy="1051560"/>
           </a:xfrm>
           <a:prstGeom prst="roundRect">
@@ -15013,7 +15142,7 @@
         </p:nvSpPr>
         <p:spPr>
           <a:xfrm>
-            <a:off x="4568952" y="5074919"/>
+            <a:off x="4568952" y="4983479"/>
             <a:ext cx="3060192" cy="365760"/>
           </a:xfrm>
           <a:prstGeom prst="rect">
@@ -15058,7 +15187,7 @@
         </p:nvSpPr>
         <p:spPr>
           <a:xfrm>
-            <a:off x="4568952" y="5513831"/>
+            <a:off x="4568952" y="5422392"/>
             <a:ext cx="3060192" cy="457200"/>
           </a:xfrm>
           <a:prstGeom prst="rect">
@@ -15119,7 +15248,7 @@
         </p:nvSpPr>
         <p:spPr>
           <a:xfrm>
-            <a:off x="8004048" y="4983479"/>
+            <a:off x="8004048" y="4892040"/>
             <a:ext cx="3352800" cy="1051560"/>
           </a:xfrm>
           <a:prstGeom prst="roundRect">
@@ -15167,7 +15296,7 @@
         </p:nvSpPr>
         <p:spPr>
           <a:xfrm>
-            <a:off x="8150352" y="5074919"/>
+            <a:off x="8150352" y="4983479"/>
             <a:ext cx="3060192" cy="365760"/>
           </a:xfrm>
           <a:prstGeom prst="rect">
@@ -15212,7 +15341,7 @@
         </p:nvSpPr>
         <p:spPr>
           <a:xfrm>
-            <a:off x="8150352" y="5513831"/>
+            <a:off x="8150352" y="5422392"/>
             <a:ext cx="3060192" cy="457200"/>
           </a:xfrm>
           <a:prstGeom prst="rect">
@@ -15273,7 +15402,7 @@
         </p:nvSpPr>
         <p:spPr>
           <a:xfrm>
-            <a:off x="841248" y="6126479"/>
+            <a:off x="841248" y="6035040"/>
             <a:ext cx="10515600" cy="274320"/>
           </a:xfrm>
           <a:prstGeom prst="rect">
@@ -16002,7 +16131,7 @@
                 </a:solidFill>
                 <a:latin typeface="Calibri"/>
               </a:rPr>
-              <a:t>Docker   ·   pytest — 78 offline tests   ·   GitHub Actions-ready CLI</a:t>
+              <a:t>Docker   ·   pytest — 78 offline tests   ·   Makefile: one command per step</a:t>
             </a:r>
           </a:p>
         </p:txBody>
@@ -16315,7 +16444,7 @@
                 </a:solidFill>
                 <a:latin typeface="Calibri"/>
               </a:rPr>
-              <a:t>~0.04 ms</a:t>
+              <a:t>&lt; 0.1 ms</a:t>
             </a:r>
           </a:p>
           <a:p>
@@ -20760,7 +20889,7 @@
                 </a:solidFill>
                 <a:latin typeface="Calibri"/>
               </a:rPr>
-              <a:t>Cross-version code retrieval is under-solved territory — PRISM cohorts have taken this to IEEE.</a:t>
+              <a:t>Cross-version code retrieval is under-explored; write up these ablation findings as a short paper.</a:t>
             </a:r>
           </a:p>
         </p:txBody>

</xml_diff>

<commit_message>
Report real per-query latency and the cross-version tie
The demo's "mean query latency" timed only the ranking loop: batch_search()
books query encoding under encode_seconds. With e5-base-v2 on CPU a query
takes about 42 ms end to end, not 0.03 ms.

- Demo: print the end-to-end latency of the demo queries (encode + rank)
  and, labelled separately, the ranking step alone.
- Versioned demo: state whether stable-core + delta beats, ties or trails
  naive on this run, instead of a fixed note that the gain appears on the
  semantic backend. It ties naive offline and on e5-base-v2.
- README and the evolutionary.py docstring: the version-delta representation
  is a prototype with no measured gain yet; the cheap rebuild (P1) works.
- Deck: slides 5 and 6 show ~42 ms per query; slides 3, 8, 9 and 10 state
  the cross-version tie.
</commit_message>
<xml_diff>
--- a/submission/Thapar_Trace_Submission_ppt.pptx
+++ b/submission/Thapar_Trace_Submission_ppt.pptx
@@ -607,7 +607,7 @@
           <a:lstStyle/>
           <a:p>
             <a:r>
-              <a:t>The lesson from ten real ablations: the gains came from picking a stronger general retrieval model — e5-base-v2, trained for query→passage retrieval, beat a same-size sentence-similarity model by a third — while every code-specialized swap lost. Next steps: re-test HyDE, multi-view and front-loading on top of e5; try e5-large-v2 within the CPU budget; then validate cross-version retrieval on real multi-version repositories — every step still measured against the current best.</a:t>
+              <a:t>The lesson from ten real ablations: the gains came from picking a stronger general retrieval model — e5-base-v2, trained for query→passage retrieval, beat a same-size sentence-similarity model by a third — while every code-specialized swap lost. Next steps: re-test HyDE, multi-view and front-loading on top of e5; try e5-large-v2 within the CPU budget; make the version-delta representation beat naive retrieval (it ties so far, even on e5), then test it on real multi-version repositories — every step still measured against the current best.</a:t>
             </a:r>
           </a:p>
         </p:txBody>
@@ -1113,7 +1113,7 @@
           <a:lstStyle/>
           <a:p>
             <a:r>
-              <a:t>The demo shows retrieval working on real behavioral queries — 'find two numbers that sum to a target', 'detect if a string is a palindrome' — with the right snippet ranked first in every case. This is the offline demo (hashing backend, no downloads), so the latency shown is that backend's: under 0.1 ms per query. With the submitted model, the full real eval (3,765 long problem statements against 8,765 solutions) ran in 84 minutes on a free Kaggle CPU, no GPU. The pipeline and ranking code are the same ones the leaderboard run uses; the submitted model swaps in by config. No LLM in the ranking loop.</a:t>
+              <a:t>The demo shows retrieval working on real behavioral queries — 'find two numbers that sum to a target', 'detect if a string is a palindrome' — with the right snippet ranked first in every case. This is the offline demo (hashing backend, no downloads), so the latency shown is that backend's. With the submitted model, a query takes about 42 ms end to end on CPU (embedding the query plus ranking), and the full real eval (3,765 long problem statements against 8,765 solutions) ran in 84 minutes on a free Kaggle CPU, no GPU. The pipeline and ranking code are the same ones the leaderboard run uses; the submitted model swaps in by config. No LLM in the ranking loop.</a:t>
             </a:r>
           </a:p>
         </p:txBody>
@@ -1323,7 +1323,7 @@
           <a:lstStyle/>
           <a:p>
             <a:r>
-              <a:t>Submitted: e5-base-v2 with its query:/passage: prefixes and a 512-token window, NDCG@10 = 0.1151, MRR@10 = 0.0986 on the real CoIR AppsRetrieval test split via MTEB — +73.9% over the MiniLM baseline (0.0662). Ten configs measured, one kept. The pipeline differentiators on the left all lost to baseline on MiniLM — multi-view (−22%), HyDE (−6%), front-load keywords (−2.4%) — and so did every code-specialized model: UniXcoder (−34.5%), CodeSearchNet (−50%). What won was a stronger general model: mpnet (+30.1% at 512 tokens), then e5-base-v2, the same size but trained for query→passage retrieval (+33.7% over mpnet). Limitations up front: larger models are untested within the CPU budget, and the dropped features haven't been re-measured on e5.</a:t>
+              <a:t>Submitted: e5-base-v2 with its query:/passage: prefixes and a 512-token window, NDCG@10 = 0.1151, MRR@10 = 0.0986 on the real CoIR AppsRetrieval test split via MTEB — +73.9% over the MiniLM baseline (0.0662). Ten configs measured, one kept. The pipeline differentiators on the left all lost to baseline on MiniLM — multi-view (−22%), HyDE (−6%), front-load keywords (−2.4%) — and so did every code-specialized model: UniXcoder (−34.5%), CodeSearchNet (−50%). What won was a stronger general model: mpnet (+30.1% at 512 tokens), then e5-base-v2, the same size but trained for query→passage retrieval (+33.7% over mpnet). Limitations up front: larger models are untested within the CPU budget, the dropped features haven't been re-measured on e5, and the version-delta representation ties naive retrieval even on e5, so the cross-version bonus is a prototype without a measured gain yet.</a:t>
             </a:r>
           </a:p>
         </p:txBody>
@@ -6103,7 +6103,7 @@
                 </a:solidFill>
                 <a:latin typeface="Calibri"/>
               </a:rPr>
-              <a:t>prism/index/versioned.py + stable-core / version-delta — the P1 requirement is a first-class feature.</a:t>
+              <a:t>prism/index/versioned.py — a new version re-encodes only the snippets that changed (1 of 18 in the demo).</a:t>
             </a:r>
           </a:p>
         </p:txBody>
@@ -12352,7 +12352,7 @@
                 </a:solidFill>
                 <a:latin typeface="Calibri"/>
               </a:rPr>
-              <a:t>Measured on the real split: rows 1 and 3 (HyDE, multi-view) lost and are off; what moved the score was a retrieval-trained encoder, e5-base-v2.</a:t>
+              <a:t>Measured: rows 1 and 3 (HyDE, multi-view) lost and are off; row 4's version-delta ties naive retrieval; e5-base-v2 is what moved the score.</a:t>
             </a:r>
           </a:p>
         </p:txBody>
@@ -14595,7 +14595,7 @@
                 </a:solidFill>
                 <a:latin typeface="Courier New"/>
               </a:rPr>
-              <a:t>  1. [two_sum]         score=0.3810</a:t>
+              <a:t>  1. [two_sum]            score=0.3810</a:t>
             </a:r>
           </a:p>
           <a:p>
@@ -14614,7 +14614,7 @@
                 </a:solidFill>
                 <a:latin typeface="Courier New"/>
               </a:rPr>
-              <a:t>  2. [binary_search]   score=0.1483</a:t>
+              <a:t>  2. [binary_search]      score=0.1483</a:t>
             </a:r>
           </a:p>
           <a:p>
@@ -14633,26 +14633,7 @@
                 </a:solidFill>
                 <a:latin typeface="Courier New"/>
               </a:rPr>
-              <a:t> </a:t>
-            </a:r>
-          </a:p>
-          <a:p>
-            <a:pPr algn="l">
-              <a:spcBef>
-                <a:spcPts val="0"/>
-              </a:spcBef>
-              <a:spcAft>
-                <a:spcPts val="500"/>
-              </a:spcAft>
-            </a:pPr>
-            <a:r>
-              <a:rPr sz="1200" b="1" i="0">
-                <a:solidFill>
-                  <a:srgbClr val="8FD9A8"/>
-                </a:solidFill>
-                <a:latin typeface="Courier New"/>
-              </a:rPr>
-              <a:t>mean query latency: 0.03 ms (31584 q/s)</a:t>
+              <a:t>  3. [lru_cache_manual]   score=0.0785</a:t>
             </a:r>
           </a:p>
         </p:txBody>
@@ -14740,7 +14721,7 @@
                 </a:solidFill>
                 <a:latin typeface="Calibri"/>
               </a:rPr>
-              <a:t>&lt; 0.1 ms</a:t>
+              <a:t>~42 ms</a:t>
             </a:r>
           </a:p>
           <a:p>
@@ -14759,7 +14740,26 @@
                 </a:solidFill>
                 <a:latin typeface="Calibri"/>
               </a:rPr>
-              <a:t>per query, offline demo backend</a:t>
+              <a:t>per query, end to end</a:t>
+            </a:r>
+          </a:p>
+          <a:p>
+            <a:pPr algn="ctr">
+              <a:spcBef>
+                <a:spcPts val="0"/>
+              </a:spcBef>
+              <a:spcAft>
+                <a:spcPts val="0"/>
+              </a:spcAft>
+            </a:pPr>
+            <a:r>
+              <a:rPr sz="1100" b="0" i="0">
+                <a:solidFill>
+                  <a:srgbClr val="6B6B76"/>
+                </a:solidFill>
+                <a:latin typeface="Calibri"/>
+              </a:rPr>
+              <a:t>e5-base-v2 on CPU</a:t>
             </a:r>
           </a:p>
         </p:txBody>
@@ -16444,7 +16444,7 @@
                 </a:solidFill>
                 <a:latin typeface="Calibri"/>
               </a:rPr>
-              <a:t>&lt; 0.1 ms</a:t>
+              <a:t>~42 ms</a:t>
             </a:r>
           </a:p>
           <a:p>
@@ -16463,7 +16463,7 @@
                 </a:solidFill>
                 <a:latin typeface="Calibri"/>
               </a:rPr>
-              <a:t>offline demo latency</a:t>
+              <a:t>per query, e5 on CPU</a:t>
             </a:r>
           </a:p>
         </p:txBody>
@@ -19677,7 +19677,7 @@
                 </a:solidFill>
                 <a:latin typeface="Calibri"/>
               </a:rPr>
-              <a:t>—  CPU-only caps model size by design — the trade this theme asks for</a:t>
+              <a:t>—  CPU-only by design; larger models (e.g. e5-large, ~3× CPU) untested</a:t>
             </a:r>
           </a:p>
           <a:p>
@@ -19699,7 +19699,7 @@
                 </a:solidFill>
                 <a:latin typeface="Calibri"/>
               </a:rPr>
-              <a:t>—  Larger retrieval models (e.g. e5-large) untested — ~3× the CPU time</a:t>
+              <a:t>—  HyDE, multi-view, front-load not yet re-measured on top of e5</a:t>
             </a:r>
           </a:p>
           <a:p>
@@ -19721,7 +19721,7 @@
                 </a:solidFill>
                 <a:latin typeface="Calibri"/>
               </a:rPr>
-              <a:t>—  HyDE, multi-view, front-load not yet re-measured on top of e5</a:t>
+              <a:t>—  Version-delta ties naive retrieval, even on e5: no cross-version gain yet</a:t>
             </a:r>
           </a:p>
         </p:txBody>
@@ -20525,7 +20525,7 @@
                 </a:solidFill>
                 <a:latin typeface="Calibri"/>
               </a:rPr>
-              <a:t>Validate at scale</a:t>
+              <a:t>Cross-version gain</a:t>
             </a:r>
           </a:p>
         </p:txBody>
@@ -20658,7 +20658,7 @@
                 </a:solidFill>
                 <a:latin typeface="Calibri"/>
               </a:rPr>
-              <a:t>Prove cross-version retrieval on real multi-version repositories, not just the prototype set.</a:t>
+              <a:t>Version-delta ties naive retrieval so far, even on e5. Make it win, then test on real multi-version repos.</a:t>
             </a:r>
           </a:p>
         </p:txBody>

</xml_diff>